<commit_message>
Added last copy of project
</commit_message>
<xml_diff>
--- a/Presentation/Mapping Real Estate in Egypt.pptx
+++ b/Presentation/Mapping Real Estate in Egypt.pptx
@@ -348,7 +348,7 @@
             <a:fld id="{1D8BD707-D9CF-40AE-B4C6-C98DA3205C09}" type="datetimeFigureOut">
               <a:rPr lang="en-US" smtClean="0"/>
               <a:pPr/>
-              <a:t>4/30/2026</a:t>
+              <a:t>5/6/2026</a:t>
             </a:fld>
             <a:endParaRPr lang="en-US"/>
           </a:p>
@@ -513,7 +513,7 @@
             <a:fld id="{1D8BD707-D9CF-40AE-B4C6-C98DA3205C09}" type="datetimeFigureOut">
               <a:rPr lang="en-US" smtClean="0"/>
               <a:pPr/>
-              <a:t>4/30/2026</a:t>
+              <a:t>5/6/2026</a:t>
             </a:fld>
             <a:endParaRPr lang="en-US"/>
           </a:p>
@@ -688,7 +688,7 @@
             <a:fld id="{1D8BD707-D9CF-40AE-B4C6-C98DA3205C09}" type="datetimeFigureOut">
               <a:rPr lang="en-US" smtClean="0"/>
               <a:pPr/>
-              <a:t>4/30/2026</a:t>
+              <a:t>5/6/2026</a:t>
             </a:fld>
             <a:endParaRPr lang="en-US"/>
           </a:p>
@@ -853,7 +853,7 @@
             <a:fld id="{1D8BD707-D9CF-40AE-B4C6-C98DA3205C09}" type="datetimeFigureOut">
               <a:rPr lang="en-US" smtClean="0"/>
               <a:pPr/>
-              <a:t>4/30/2026</a:t>
+              <a:t>5/6/2026</a:t>
             </a:fld>
             <a:endParaRPr lang="en-US"/>
           </a:p>
@@ -1095,7 +1095,7 @@
             <a:fld id="{1D8BD707-D9CF-40AE-B4C6-C98DA3205C09}" type="datetimeFigureOut">
               <a:rPr lang="en-US" smtClean="0"/>
               <a:pPr/>
-              <a:t>4/30/2026</a:t>
+              <a:t>5/6/2026</a:t>
             </a:fld>
             <a:endParaRPr lang="en-US"/>
           </a:p>
@@ -1377,7 +1377,7 @@
             <a:fld id="{1D8BD707-D9CF-40AE-B4C6-C98DA3205C09}" type="datetimeFigureOut">
               <a:rPr lang="en-US" smtClean="0"/>
               <a:pPr/>
-              <a:t>4/30/2026</a:t>
+              <a:t>5/6/2026</a:t>
             </a:fld>
             <a:endParaRPr lang="en-US"/>
           </a:p>
@@ -1793,7 +1793,7 @@
             <a:fld id="{1D8BD707-D9CF-40AE-B4C6-C98DA3205C09}" type="datetimeFigureOut">
               <a:rPr lang="en-US" smtClean="0"/>
               <a:pPr/>
-              <a:t>4/30/2026</a:t>
+              <a:t>5/6/2026</a:t>
             </a:fld>
             <a:endParaRPr lang="en-US"/>
           </a:p>
@@ -1907,7 +1907,7 @@
             <a:fld id="{1D8BD707-D9CF-40AE-B4C6-C98DA3205C09}" type="datetimeFigureOut">
               <a:rPr lang="en-US" smtClean="0"/>
               <a:pPr/>
-              <a:t>4/30/2026</a:t>
+              <a:t>5/6/2026</a:t>
             </a:fld>
             <a:endParaRPr lang="en-US"/>
           </a:p>
@@ -1999,7 +1999,7 @@
             <a:fld id="{1D8BD707-D9CF-40AE-B4C6-C98DA3205C09}" type="datetimeFigureOut">
               <a:rPr lang="en-US" smtClean="0"/>
               <a:pPr/>
-              <a:t>4/30/2026</a:t>
+              <a:t>5/6/2026</a:t>
             </a:fld>
             <a:endParaRPr lang="en-US"/>
           </a:p>
@@ -2271,7 +2271,7 @@
             <a:fld id="{1D8BD707-D9CF-40AE-B4C6-C98DA3205C09}" type="datetimeFigureOut">
               <a:rPr lang="en-US" smtClean="0"/>
               <a:pPr/>
-              <a:t>4/30/2026</a:t>
+              <a:t>5/6/2026</a:t>
             </a:fld>
             <a:endParaRPr lang="en-US"/>
           </a:p>
@@ -2520,7 +2520,7 @@
             <a:fld id="{1D8BD707-D9CF-40AE-B4C6-C98DA3205C09}" type="datetimeFigureOut">
               <a:rPr lang="en-US" smtClean="0"/>
               <a:pPr/>
-              <a:t>4/30/2026</a:t>
+              <a:t>5/6/2026</a:t>
             </a:fld>
             <a:endParaRPr lang="en-US"/>
           </a:p>
@@ -2728,7 +2728,7 @@
             <a:fld id="{1D8BD707-D9CF-40AE-B4C6-C98DA3205C09}" type="datetimeFigureOut">
               <a:rPr lang="en-US" smtClean="0"/>
               <a:pPr/>
-              <a:t>4/30/2026</a:t>
+              <a:t>5/6/2026</a:t>
             </a:fld>
             <a:endParaRPr lang="en-US"/>
           </a:p>
@@ -3943,7 +3943,7 @@
               </a:lnSpc>
             </a:pPr>
             <a:r>
-              <a:rPr lang="en-US" sz="8400" b="1" i="1">
+              <a:rPr lang="en-US" sz="8400" b="1" i="1" dirty="0">
                 <a:solidFill>
                   <a:srgbClr val="FFFFFF"/>
                 </a:solidFill>
@@ -9918,10 +9918,10 @@
         <mc:Choice xmlns:we="http://schemas.microsoft.com/office/webextensions/webextension/2010/11" xmlns:pca="http://schemas.microsoft.com/office/powerpoint/2013/contentapp" Requires="we pca">
           <p:graphicFrame>
             <p:nvGraphicFramePr>
-              <p:cNvPr id="6" name="Add-in" descr="Add-in content for Microsoft Power BI.">
+              <p:cNvPr id="9" name="Add-in" descr="Add-in content for Microsoft Power BI.">
                 <a:extLst>
                   <a:ext uri="{FF2B5EF4-FFF2-40B4-BE49-F238E27FC236}">
-                    <a16:creationId xmlns:a16="http://schemas.microsoft.com/office/drawing/2014/main" id="{B067B31F-A5EC-7979-7E2C-3552A36B34D9}"/>
+                    <a16:creationId xmlns:a16="http://schemas.microsoft.com/office/drawing/2014/main" id="{E96A2F70-33CE-5F83-AA87-73F31046ABE5}"/>
                   </a:ext>
                 </a:extLst>
               </p:cNvPr>
@@ -9931,14 +9931,14 @@
               <p:nvPr>
                 <p:extLst>
                   <p:ext uri="{D42A27DB-BD31-4B8C-83A1-F6EECF244321}">
-                    <p14:modId xmlns:p14="http://schemas.microsoft.com/office/powerpoint/2010/main" val="403330471"/>
+                    <p14:modId xmlns:p14="http://schemas.microsoft.com/office/powerpoint/2010/main" val="2684369170"/>
                   </p:ext>
                 </p:extLst>
               </p:nvPr>
             </p:nvGraphicFramePr>
             <p:xfrm>
-              <a:off x="1600200" y="1855131"/>
-              <a:ext cx="14478000" cy="7832859"/>
+              <a:off x="1253503" y="1855131"/>
+              <a:ext cx="15780994" cy="7832859"/>
             </p:xfrm>
             <a:graphic>
               <a:graphicData uri="http://schemas.microsoft.com/office/webextensions/webextension/2010/11">
@@ -9950,10 +9950,10 @@
         <mc:Fallback>
           <p:pic>
             <p:nvPicPr>
-              <p:cNvPr id="6" name="Add-in" descr="Add-in content for Microsoft Power BI.">
+              <p:cNvPr id="9" name="Add-in" descr="Add-in content for Microsoft Power BI.">
                 <a:extLst>
                   <a:ext uri="{FF2B5EF4-FFF2-40B4-BE49-F238E27FC236}">
-                    <a16:creationId xmlns:a16="http://schemas.microsoft.com/office/drawing/2014/main" id="{B067B31F-A5EC-7979-7E2C-3552A36B34D9}"/>
+                    <a16:creationId xmlns:a16="http://schemas.microsoft.com/office/drawing/2014/main" id="{E96A2F70-33CE-5F83-AA87-73F31046ABE5}"/>
                   </a:ext>
                 </a:extLst>
               </p:cNvPr>
@@ -9970,8 +9970,8 @@
             </p:blipFill>
             <p:spPr>
               <a:xfrm>
-                <a:off x="1600200" y="1855131"/>
-                <a:ext cx="14478000" cy="7832859"/>
+                <a:off x="1253503" y="1855131"/>
+                <a:ext cx="15780994" cy="7832859"/>
               </a:xfrm>
               <a:prstGeom prst="rect">
                 <a:avLst/>
@@ -24480,28 +24480,28 @@
 </file>
 
 <file path=ppt/webextensions/webextension1.xml><?xml version="1.0" encoding="utf-8"?>
-<we:webextension xmlns:we="http://schemas.microsoft.com/office/webextensions/webextension/2010/11" id="{C820C1F3-5C5C-4474-AC10-7E3878BACB7B}">
+<we:webextension xmlns:we="http://schemas.microsoft.com/office/webextensions/webextension/2010/11" id="{EC520673-3D57-40DE-BAC5-FB22247BEDE6}">
   <we:reference id="WA200003233" version="2.0.0.3" store="en-US" storeType="OMEX"/>
   <we:alternateReferences/>
   <we:properties>
     <we:property name="Microsoft.Office.CampaignId" value="&quot;none&quot;"/>
     <we:property name="artifactViewState" value="&quot;live&quot;"/>
     <we:property name="backgroundColor" value="&quot;#FFFFFF&quot;"/>
-    <we:property name="bookmark" value="&quot;H4sIAAAAAAAAA6VVTW/bMAz9K4PPwUDqW7t1w05dP7AOvRTFQFF04dWJA9sp2hX975OSAr20COBdbImm3nukSPO5yd207enpnNbSfGm+DsP9msb7T9isms2r7eLi9Ozk5+nv85Oz78U8bOdu2EzNl+dmpvFO5utu2lFfEYrx5nbVUN9f0l3dtdRPsmq2Mk7Dhvrurxycy6d53MnLqpHHbT+MVCGvZpqlwj4U97Iv3PhZF0biuXuQK+H5YPUpxCix1UiaiW1g4OI2HRz2yt51qdB7+m/DZqZuU2iqTeU2M3uQ6DRA8czeVvvUbe76V8FvZ389bWtWunWJsGYj/Sm0FeflpYQTCGIrbetJ2ewwe8qwFCsiK06gnASnnEflSZZieeXZOGmTR405Wa8NL8XKwaQY0ObspWjCbJRZikU5g3MKAHQGLVYl8kux0KYUo7WWgFiBmJQW6zKpFAFoZyEBYLYZl2NBi4CM5NgHLJfgANXiGJ3RGnUgj04LWPJ2ca2ic61CFmvQimPSCMdrYpbHOQ2P71S+BAFvQtKWEIwS0HGpMqtzjMBK0IFmW8pNHa/8D5Wx8a1YLMnSpaEgJR/+Aw2wSmLx7GIWBohCy9FUssq1JtpQ7jMQh+SO18aHaMa19cdHDnwEAzE7u7ibXNYuBcuawUVvOSlcjBVLgM5HZRFVsMAmq8W14Zzl0k8tJCytKZI4h6UZ2wO+WZq1lHlWF8NunrbEckmbsr95brbjUIbY3Mnerwwt2mTJr+uxvn90s4wH6mvqd5V1P/2aPUlR06VejhyoM7HZy7qtj39IeRmtngcAAA==&quot;"/>
-    <we:property name="creatorSessionId" value="&quot;8cc895e2-cf6a-4269-9d80-6628e3c42c46&quot;"/>
+    <we:property name="bookmark" value="&quot;H4sIAAAAAAAAA+1aWW/bRhD+KwGfhWLvw2+x6wABitSN0/ShCILZ3aHMhCZVinLtGvrvHZJS2iimGci5nFhP5HL07dzHktdZKpaLEq6ewTlmB9lhXb89h+btI57NsmpYEy7lEjhHY6U3uYzJB3paL9qirpbZwXXWQjPH9mWxXEHZAdHin69mGZTlCcy7uxzKJc6yBTbLuoKy+AcHYnrUNitczzK8XJR1Ax3kaQstdrAXRE73xAL/SdKOENviAk8xtsOqlshznotkjEQtZEIZiWw5EPSc3UhC63lRtoTeXYar48tFQxxfbwWOhjtFhIlZBGCMpdBt314tuqdHxN28booIZdbz3eByYPM6O6rL1Xl/dfze+mm9aiI+x7x/VLVFe0VIzxHK18fLTtzXx/OrRZutSRMnTU166gmOOrpu7az++6hBokvZAV+/opWLXn9HddVCUW0ksTlID0q5IBIDdMxa160vi2pebjTe67W/ejGIU5yTiTpzhjektw5n3e2YjMDojfVCIOlBM8H8JFaLl22oLz9EMyF3mmmlA0DkSUiIuD+aNgmN6IzKrYvMSsWm0ZZnsLhBTq4UYxock+DJ7J5xxvbFMgZiMs5Jo9E5E73m0/ofwVIxyNxyY7RFVCSwQ7kvFnmCpgBWIJ1ySkrvjd4bC5kNQkWHzAeLMSo3rfsRH/Mojc2VI53HEFlKyam9dc9Yzhx5mBXSW6fBsL2xgDsMLEopoyZRbXBM7IslQHElXTRgjLKS2RT21hdKz6VzUVhrKZSUgTTtEyNYWkurjPacOZksWGbCdHyPYBnUmufKs6Q9RRLwGOP+0e2ctqHLFTxZz1FbbaelHEVTzAjtvaYUFgMZAJkz+6NFy1SMgXHPIfHAGWWz/dGCyYN3jHGwjtvEfBJ6vDhtys/jdAFVpEKwW3sez+cNzqHd3B5/zsJ0QuUP+8Unq2pTjvluoWJ9obpVNRGa9L5e6KZJ2Bxe9TL/XDTbai9mO6x/A/KSgLRkc0o9OpcMEaw1DJjn98OMj8lUP5AVbxZ3MCIP0uUWKbOGZKglCF6o+2HEo/p8Ua+qtCOZ+I4NOS7yYEwBQSnjAqMKDoabqIO4H8bsDfHjGPJmcQcjRutyJjwzNDlQUpUGXbpD5RbC0sSgPXXTDqyR8SNmhvF5RmsdkAYQSy0do9aV5qT90YThmFsaF1AD5R3vbLwDmsdcJRcBqIWK0tBE46a7sbFuX9LUTKoS0nqmuz4qTXeJY5NW1BolCKaNoKbMepoeJoPyaw/bbD37thLEJ+u8ytWS1I7pEJqjM2ja+5AuRtuw7dkQ0b753+nPxnsGIT6Pu7zaRDBVG6+ikTQrBk5DlZ8uOF/Qt3+vivbRafEPPnqnkts8/SHqdrh8WiW83HE8fZeoG/i7N4E3Iv9XCbwbfXkIQ80ijeQmGusYj4klz/Y/gJOeGwwJqVaBdsr5/Q+UZFQ6BcO740Fk1gVhYDI9vKgXzwhqoOlIXm6Pw8kVnjT1eU+8ObdfrsJfKyRV7HrJ6fYBXf+2vbgNqekgxo0xG3q2ztln2SmWJObHG3m46Te5sRGcbZnICyypu6ctfv1i0TDO3C3eT0bKDkxv5EEvoktde6jyjzNKCxtNVqnYyvF0h+vlp1N2zz6EEsf/+c6r1uu+K//MteDdNPA91IJvqZo+1KUvUJe2UbV55SK4VMwFiFFIdIpx+5DxHzL+Q8afzvj86+TOJ0VVLM8oS343JWgy7ae6WrUPyf6OzjJkfA/oOfMmME7zf4pWf8QnDiMvVGMI2oOSKXTfENDYIDhOVo970GbAJnhOyyJisyH68AVwiLkQSXImDfPKW2+nP8lYkCKfwUVBvlg3Nx2KqtzlOYsYRExBKyfCJCb0vnS4alvS1g5kj/rfSnaOzby3Ub1qlwuIeALVkN0Xg94K7OnILkB+nDbXfZn/pSCrDvu/hHLVl8Pug6ms34RYKjY5+5Y/dJ9RbZM2/f4FkQNd5NglAAA=&quot;"/>
+    <we:property name="creatorSessionId" value="&quot;cd898ce2-cf2a-4a51-8dae-08c683e6cf1b&quot;"/>
     <we:property name="creatorTenantId" value="&quot;77255288-5298-4ea5-81aa-a13e604c30ac&quot;"/>
     <we:property name="creatorUserId" value="&quot;100320053ABB8047&quot;"/>
-    <we:property name="datasetId" value="&quot;68dbb922-64f0-4db4-a830-f70893ab3a0e&quot;"/>
-    <we:property name="embedUrl" value="&quot;/reportEmbed?reportId=f7e03d6a-2cd8-451b-a97f-848154eb9697&amp;config=eyJjbHVzdGVyVXJsIjoiaHR0cHM6Ly9XQUJJLU5PUlRILUVVUk9QRS1PLVBSSU1BUlktcmVkaXJlY3QuYW5hbHlzaXMud2luZG93cy5uZXQiLCJlbWJlZEZlYXR1cmVzIjp7InVzYWdlTWV0cmljc1ZOZXh0Ijp0cnVlfX0%3D&amp;disableSensitivityBanner=true&amp;storytellingChangeViewModeShortcutKeys=true&quot;"/>
+    <we:property name="datasetId" value="&quot;8e7cd66e-3f46-40ba-8a0f-a2aa959b4b75&quot;"/>
+    <we:property name="embedUrl" value="&quot;/reportEmbed?reportId=3457b0e3-007e-4692-a894-549b02af13e0&amp;config=eyJjbHVzdGVyVXJsIjoiaHR0cHM6Ly9XQUJJLU5PUlRILUVVUk9QRS1PLVBSSU1BUlktcmVkaXJlY3QuYW5hbHlzaXMud2luZG93cy5uZXQiLCJlbWJlZEZlYXR1cmVzIjp7InVzYWdlTWV0cmljc1ZOZXh0Ijp0cnVlfX0%3D&amp;disableSensitivityBanner=true&amp;storytellingChangeViewModeShortcutKeys=true&quot;"/>
     <we:property name="initialStateBookmark" value="&quot;H4sIAAAAAAAAA6VVTW/bMAz9K4PPwUDqW7t1w05dP7AOvRTFQFF04dWJA9sp2hX975OSAr20COBdbImm3nukSPO5yd207enpnNbSfGm+DsP9msb7T9isms2r7eLi9Ozk5+nv85Oz78U8bOdu2EzNl+dmpvFO5utu2lFfEYrx5nbVUN9f0l3dtdRPsmq2Mk7Dhvrurxycy6d53MnLqpHHbT+MVCGvZpqlwj4U97Iv3PhZF0biuXuQK+H5YPUpxCix1UiaiW1g4OI2HRz2yt51qdB7+m/DZqZuU2iqTeU2M3uQ6DRA8czeVvvUbe76V8FvZ389bWtWunWJsGYj/Sm0FeflpYQTCGIrbetJ2ewwe8qwFCsiK06gnASnnEflSZZieeXZOGmTR405Wa8NL8XKwaQY0ObspWjCbJRZikU5g3MKAHQGLVYl8kux0KYUo7WWgFiBmJQW6zKpFAFoZyEBYLYZl2NBi4CM5NgHLJfgANXiGJ3RGnUgj04LWPJ2ca2ic61CFmvQimPSCMdrYpbHOQ2P71S+BAFvQtKWEIwS0HGpMqtzjMBK0IFmW8pNHa/8D5Wx8a1YLMnSpaEgJR/+Aw2wSmLx7GIWBohCy9FUssq1JtpQ7jMQh+SO18aHaMa19cdHDnwEAzE7u7ibXNYuBcuawUVvOSlcjBVLgM5HZRFVsMAmq8W14Zzl0k8tJCytKZI4h6UZ2wO+WZq1lHlWF8NunrbEckmbsr95brbjUIbY3Mnerwwt2mTJr+uxvn90s4wH6mvqd5V1P/2aPUlR06VejhyoM7HZy7qtj39IeRmtngcAAA==&quot;"/>
     <we:property name="isFiltersActionButtonVisible" value="true"/>
     <we:property name="isVisualContainerHeaderHidden" value="false"/>
-    <we:property name="pageDisplayName" value="&quot;Homepage&quot;"/>
-    <we:property name="pageName" value="&quot;7b899e9f31a3cac58c0c&quot;"/>
-    <we:property name="reportEmbeddedTime" value="&quot;2026-04-29T20:01:48.805Z&quot;"/>
-    <we:property name="reportName" value="&quot;Depi_Grad 4.1&quot;"/>
+    <we:property name="pageDisplayName" value="&quot;Market Overiew&quot;"/>
+    <we:property name="pageName" value="&quot;53e1f1f2d663e523de3c&quot;"/>
+    <we:property name="reportEmbeddedTime" value="&quot;2026-05-06T14:19:09.724Z&quot;"/>
+    <we:property name="reportName" value="&quot;Depi_Grad 4.4&quot;"/>
     <we:property name="reportState" value="&quot;CONNECTED&quot;"/>
-    <we:property name="reportUrl" value="&quot;/groups/me/reports/f7e03d6a-2cd8-451b-a97f-848154eb9697/7b899e9f31a3cac58c0c?bookmarkGuid=fbe551b7-f066-4b87-b394-0e20a77f8430&amp;bookmarkUsage=1&amp;ctid=77255288-5298-4ea5-81aa-a13e604c30ac&amp;fromEntryPoint=export&amp;pbi_source=storytelling_addin&quot;"/>
+    <we:property name="reportUrl" value="&quot;/groups/me/reports/3457b0e3-007e-4692-a894-549b02af13e0/53e1f1f2d663e523de3c?bookmarkGuid=01a64edc-4a57-423b-a5d8-0f6aa1c36b53&amp;bookmarkUsage=1&amp;ctid=77255288-5298-4ea5-81aa-a13e604c30ac&amp;fromEntryPoint=export&amp;pbi_source=storytelling_addin&quot;"/>
   </we:properties>
   <we:bindings/>
   <we:snapshot xmlns:r="http://schemas.openxmlformats.org/officeDocument/2006/relationships"/>

</xml_diff>

<commit_message>
Upload latest version of the project
</commit_message>
<xml_diff>
--- a/Presentation/Mapping Real Estate in Egypt.pptx
+++ b/Presentation/Mapping Real Estate in Egypt.pptx
@@ -348,7 +348,7 @@
             <a:fld id="{1D8BD707-D9CF-40AE-B4C6-C98DA3205C09}" type="datetimeFigureOut">
               <a:rPr lang="en-US" smtClean="0"/>
               <a:pPr/>
-              <a:t>5/6/2026</a:t>
+              <a:t>6/19/2026</a:t>
             </a:fld>
             <a:endParaRPr lang="en-US"/>
           </a:p>
@@ -513,7 +513,7 @@
             <a:fld id="{1D8BD707-D9CF-40AE-B4C6-C98DA3205C09}" type="datetimeFigureOut">
               <a:rPr lang="en-US" smtClean="0"/>
               <a:pPr/>
-              <a:t>5/6/2026</a:t>
+              <a:t>6/19/2026</a:t>
             </a:fld>
             <a:endParaRPr lang="en-US"/>
           </a:p>
@@ -688,7 +688,7 @@
             <a:fld id="{1D8BD707-D9CF-40AE-B4C6-C98DA3205C09}" type="datetimeFigureOut">
               <a:rPr lang="en-US" smtClean="0"/>
               <a:pPr/>
-              <a:t>5/6/2026</a:t>
+              <a:t>6/19/2026</a:t>
             </a:fld>
             <a:endParaRPr lang="en-US"/>
           </a:p>
@@ -853,7 +853,7 @@
             <a:fld id="{1D8BD707-D9CF-40AE-B4C6-C98DA3205C09}" type="datetimeFigureOut">
               <a:rPr lang="en-US" smtClean="0"/>
               <a:pPr/>
-              <a:t>5/6/2026</a:t>
+              <a:t>6/19/2026</a:t>
             </a:fld>
             <a:endParaRPr lang="en-US"/>
           </a:p>
@@ -1095,7 +1095,7 @@
             <a:fld id="{1D8BD707-D9CF-40AE-B4C6-C98DA3205C09}" type="datetimeFigureOut">
               <a:rPr lang="en-US" smtClean="0"/>
               <a:pPr/>
-              <a:t>5/6/2026</a:t>
+              <a:t>6/19/2026</a:t>
             </a:fld>
             <a:endParaRPr lang="en-US"/>
           </a:p>
@@ -1377,7 +1377,7 @@
             <a:fld id="{1D8BD707-D9CF-40AE-B4C6-C98DA3205C09}" type="datetimeFigureOut">
               <a:rPr lang="en-US" smtClean="0"/>
               <a:pPr/>
-              <a:t>5/6/2026</a:t>
+              <a:t>6/19/2026</a:t>
             </a:fld>
             <a:endParaRPr lang="en-US"/>
           </a:p>
@@ -1793,7 +1793,7 @@
             <a:fld id="{1D8BD707-D9CF-40AE-B4C6-C98DA3205C09}" type="datetimeFigureOut">
               <a:rPr lang="en-US" smtClean="0"/>
               <a:pPr/>
-              <a:t>5/6/2026</a:t>
+              <a:t>6/19/2026</a:t>
             </a:fld>
             <a:endParaRPr lang="en-US"/>
           </a:p>
@@ -1907,7 +1907,7 @@
             <a:fld id="{1D8BD707-D9CF-40AE-B4C6-C98DA3205C09}" type="datetimeFigureOut">
               <a:rPr lang="en-US" smtClean="0"/>
               <a:pPr/>
-              <a:t>5/6/2026</a:t>
+              <a:t>6/19/2026</a:t>
             </a:fld>
             <a:endParaRPr lang="en-US"/>
           </a:p>
@@ -1999,7 +1999,7 @@
             <a:fld id="{1D8BD707-D9CF-40AE-B4C6-C98DA3205C09}" type="datetimeFigureOut">
               <a:rPr lang="en-US" smtClean="0"/>
               <a:pPr/>
-              <a:t>5/6/2026</a:t>
+              <a:t>6/19/2026</a:t>
             </a:fld>
             <a:endParaRPr lang="en-US"/>
           </a:p>
@@ -2271,7 +2271,7 @@
             <a:fld id="{1D8BD707-D9CF-40AE-B4C6-C98DA3205C09}" type="datetimeFigureOut">
               <a:rPr lang="en-US" smtClean="0"/>
               <a:pPr/>
-              <a:t>5/6/2026</a:t>
+              <a:t>6/19/2026</a:t>
             </a:fld>
             <a:endParaRPr lang="en-US"/>
           </a:p>
@@ -2520,7 +2520,7 @@
             <a:fld id="{1D8BD707-D9CF-40AE-B4C6-C98DA3205C09}" type="datetimeFigureOut">
               <a:rPr lang="en-US" smtClean="0"/>
               <a:pPr/>
-              <a:t>5/6/2026</a:t>
+              <a:t>6/19/2026</a:t>
             </a:fld>
             <a:endParaRPr lang="en-US"/>
           </a:p>
@@ -2728,7 +2728,7 @@
             <a:fld id="{1D8BD707-D9CF-40AE-B4C6-C98DA3205C09}" type="datetimeFigureOut">
               <a:rPr lang="en-US" smtClean="0"/>
               <a:pPr/>
-              <a:t>5/6/2026</a:t>
+              <a:t>6/19/2026</a:t>
             </a:fld>
             <a:endParaRPr lang="en-US"/>
           </a:p>
@@ -9918,10 +9918,10 @@
         <mc:Choice xmlns:we="http://schemas.microsoft.com/office/webextensions/webextension/2010/11" xmlns:pca="http://schemas.microsoft.com/office/powerpoint/2013/contentapp" Requires="we pca">
           <p:graphicFrame>
             <p:nvGraphicFramePr>
-              <p:cNvPr id="9" name="Add-in" descr="Add-in content for Microsoft Power BI.">
+              <p:cNvPr id="8" name="Add-in" descr="Add-in content for Microsoft Power BI.">
                 <a:extLst>
                   <a:ext uri="{FF2B5EF4-FFF2-40B4-BE49-F238E27FC236}">
-                    <a16:creationId xmlns:a16="http://schemas.microsoft.com/office/drawing/2014/main" id="{E96A2F70-33CE-5F83-AA87-73F31046ABE5}"/>
+                    <a16:creationId xmlns:a16="http://schemas.microsoft.com/office/drawing/2014/main" id="{40B05DA0-6A7D-7AF9-3060-2AD2964CFBD0}"/>
                   </a:ext>
                 </a:extLst>
               </p:cNvPr>
@@ -9931,7 +9931,7 @@
               <p:nvPr>
                 <p:extLst>
                   <p:ext uri="{D42A27DB-BD31-4B8C-83A1-F6EECF244321}">
-                    <p14:modId xmlns:p14="http://schemas.microsoft.com/office/powerpoint/2010/main" val="2684369170"/>
+                    <p14:modId xmlns:p14="http://schemas.microsoft.com/office/powerpoint/2010/main" val="650477402"/>
                   </p:ext>
                 </p:extLst>
               </p:nvPr>
@@ -9950,10 +9950,10 @@
         <mc:Fallback>
           <p:pic>
             <p:nvPicPr>
-              <p:cNvPr id="9" name="Add-in" descr="Add-in content for Microsoft Power BI.">
+              <p:cNvPr id="8" name="Add-in" descr="Add-in content for Microsoft Power BI.">
                 <a:extLst>
                   <a:ext uri="{FF2B5EF4-FFF2-40B4-BE49-F238E27FC236}">
-                    <a16:creationId xmlns:a16="http://schemas.microsoft.com/office/drawing/2014/main" id="{E96A2F70-33CE-5F83-AA87-73F31046ABE5}"/>
+                    <a16:creationId xmlns:a16="http://schemas.microsoft.com/office/drawing/2014/main" id="{40B05DA0-6A7D-7AF9-3060-2AD2964CFBD0}"/>
                   </a:ext>
                 </a:extLst>
               </p:cNvPr>
@@ -24480,28 +24480,28 @@
 </file>
 
 <file path=ppt/webextensions/webextension1.xml><?xml version="1.0" encoding="utf-8"?>
-<we:webextension xmlns:we="http://schemas.microsoft.com/office/webextensions/webextension/2010/11" id="{EC520673-3D57-40DE-BAC5-FB22247BEDE6}">
+<we:webextension xmlns:we="http://schemas.microsoft.com/office/webextensions/webextension/2010/11" id="{12BD3FA6-6721-4465-9359-66F4849A0406}">
   <we:reference id="WA200003233" version="2.0.0.3" store="en-US" storeType="OMEX"/>
   <we:alternateReferences/>
   <we:properties>
     <we:property name="Microsoft.Office.CampaignId" value="&quot;none&quot;"/>
     <we:property name="artifactViewState" value="&quot;live&quot;"/>
     <we:property name="backgroundColor" value="&quot;#FFFFFF&quot;"/>
-    <we:property name="bookmark" value="&quot;H4sIAAAAAAAAA+1aWW/bRhD+KwGfhWLvw2+x6wABitSN0/ShCILZ3aHMhCZVinLtGvrvHZJS2iimGci5nFhP5HL07dzHktdZKpaLEq6ewTlmB9lhXb89h+btI57NsmpYEy7lEjhHY6U3uYzJB3paL9qirpbZwXXWQjPH9mWxXEHZAdHin69mGZTlCcy7uxzKJc6yBTbLuoKy+AcHYnrUNitczzK8XJR1Ax3kaQstdrAXRE73xAL/SdKOENviAk8xtsOqlshznotkjEQtZEIZiWw5EPSc3UhC63lRtoTeXYar48tFQxxfbwWOhjtFhIlZBGCMpdBt314tuqdHxN28booIZdbz3eByYPM6O6rL1Xl/dfze+mm9aiI+x7x/VLVFe0VIzxHK18fLTtzXx/OrRZutSRMnTU166gmOOrpu7az++6hBokvZAV+/opWLXn9HddVCUW0ksTlID0q5IBIDdMxa160vi2pebjTe67W/ejGIU5yTiTpzhjektw5n3e2YjMDojfVCIOlBM8H8JFaLl22oLz9EMyF3mmmlA0DkSUiIuD+aNgmN6IzKrYvMSsWm0ZZnsLhBTq4UYxock+DJ7J5xxvbFMgZiMs5Jo9E5E73m0/ofwVIxyNxyY7RFVCSwQ7kvFnmCpgBWIJ1ySkrvjd4bC5kNQkWHzAeLMSo3rfsRH/Mojc2VI53HEFlKyam9dc9Yzhx5mBXSW6fBsL2xgDsMLEopoyZRbXBM7IslQHElXTRgjLKS2RT21hdKz6VzUVhrKZSUgTTtEyNYWkurjPacOZksWGbCdHyPYBnUmufKs6Q9RRLwGOP+0e2ctqHLFTxZz1FbbaelHEVTzAjtvaYUFgMZAJkz+6NFy1SMgXHPIfHAGWWz/dGCyYN3jHGwjtvEfBJ6vDhtys/jdAFVpEKwW3sez+cNzqHd3B5/zsJ0QuUP+8Unq2pTjvluoWJ9obpVNRGa9L5e6KZJ2Bxe9TL/XDTbai9mO6x/A/KSgLRkc0o9OpcMEaw1DJjn98OMj8lUP5AVbxZ3MCIP0uUWKbOGZKglCF6o+2HEo/p8Ua+qtCOZ+I4NOS7yYEwBQSnjAqMKDoabqIO4H8bsDfHjGPJmcQcjRutyJjwzNDlQUpUGXbpD5RbC0sSgPXXTDqyR8SNmhvF5RmsdkAYQSy0do9aV5qT90YThmFsaF1AD5R3vbLwDmsdcJRcBqIWK0tBE46a7sbFuX9LUTKoS0nqmuz4qTXeJY5NW1BolCKaNoKbMepoeJoPyaw/bbD37thLEJ+u8ytWS1I7pEJqjM2ja+5AuRtuw7dkQ0b753+nPxnsGIT6Pu7zaRDBVG6+ikTQrBk5DlZ8uOF/Qt3+vivbRafEPPnqnkts8/SHqdrh8WiW83HE8fZeoG/i7N4E3Iv9XCbwbfXkIQ80ijeQmGusYj4klz/Y/gJOeGwwJqVaBdsr5/Q+UZFQ6BcO740Fk1gVhYDI9vKgXzwhqoOlIXm6Pw8kVnjT1eU+8ObdfrsJfKyRV7HrJ6fYBXf+2vbgNqekgxo0xG3q2ztln2SmWJObHG3m46Te5sRGcbZnICyypu6ctfv1i0TDO3C3eT0bKDkxv5EEvoktde6jyjzNKCxtNVqnYyvF0h+vlp1N2zz6EEsf/+c6r1uu+K//MteDdNPA91IJvqZo+1KUvUJe2UbV55SK4VMwFiFFIdIpx+5DxHzL+Q8afzvj86+TOJ0VVLM8oS343JWgy7ae6WrUPyf6OzjJkfA/oOfMmME7zf4pWf8QnDiMvVGMI2oOSKXTfENDYIDhOVo970GbAJnhOyyJisyH68AVwiLkQSXImDfPKW2+nP8lYkCKfwUVBvlg3Nx2KqtzlOYsYRExBKyfCJCb0vnS4alvS1g5kj/rfSnaOzby3Ub1qlwuIeALVkN0Xg94K7OnILkB+nDbXfZn/pSCrDvu/hHLVl8Pug6ms34RYKjY5+5Y/dJ9RbZM2/f4FkQNd5NglAAA=&quot;"/>
-    <we:property name="creatorSessionId" value="&quot;cd898ce2-cf2a-4a51-8dae-08c683e6cf1b&quot;"/>
+    <we:property name="bookmark" value="&quot;H4sIAAAAAAAAA6WVTWvcMBCG/0rxeSkz+laP7bWUQEouIYfRaBzceO3F9oakIf+90m4gl4QF9WJLo9Ezr6SR5qXLw3oY6fkX7aX71n2f54c9LQ9fsNt109nGJliEnhwBJpucFyNldD5swzyt3beXbqPlXrabYT3SWEHFeHu362gcr+i+9noaV9l1B1nWeaJx+Ctn5zK0LUd53XXydBjnhSryeqNNKvaxuJd+kYBfdYlIvA2Pci28na0+hRgl9hpJM7ENDFzc1rPDSdmHLhV9Cv9jnjYaphKm2lTuM7MHiU4DFM/sbbWvw3Q/vgl+n/v7+VA3Z9iXFdbdSH9K2Mp5fS3LCQSxl773pGx2mD1laGVFZMUJlJPglPOoPEkryyvPxkmfPGrMyXptuJWVg0kxoM3ZS9GE2SjTyqKcwTkFADqDFqsS+VYW2pRitNYSECsQk1KzLpNKEoB2FhIAZpuxnQU9AjKSYx+wHIIDVM1rdEZr1IE8Oi1gydvmXEXneoUs1qAVx6QRLufEJk9bmp8+yHwJAt6EpC0hGCWgY6syq3OMwErQgWZb0k1dzvxPlbHxvZSXzJanQDGk5MN/0ACrJBbPLmZhgCjUTlPJKtebaEM5z0AckrucG5/SjOvrw0cOfAQDMTvbfJtc1i4Fy5rBRW85KWxmxbJA56OyiCpYYJNVc244Z7ncpx4SlqspkjiH1h07Ad8t3V5KPauN+bitB2K5oqn0b1+6wzKXIrYNcvIrRYumLPmtvdT/z2GT5Rz6hsZjjXqqft0pSFEzpFEuTKg1sTvJuquff1PPwIalBwAA&quot;"/>
+    <we:property name="creatorSessionId" value="&quot;437263ec-115b-4b1e-9d92-d5d20bfd4193&quot;"/>
     <we:property name="creatorTenantId" value="&quot;77255288-5298-4ea5-81aa-a13e604c30ac&quot;"/>
     <we:property name="creatorUserId" value="&quot;100320053ABB8047&quot;"/>
-    <we:property name="datasetId" value="&quot;8e7cd66e-3f46-40ba-8a0f-a2aa959b4b75&quot;"/>
-    <we:property name="embedUrl" value="&quot;/reportEmbed?reportId=3457b0e3-007e-4692-a894-549b02af13e0&amp;config=eyJjbHVzdGVyVXJsIjoiaHR0cHM6Ly9XQUJJLU5PUlRILUVVUk9QRS1PLVBSSU1BUlktcmVkaXJlY3QuYW5hbHlzaXMud2luZG93cy5uZXQiLCJlbWJlZEZlYXR1cmVzIjp7InVzYWdlTWV0cmljc1ZOZXh0Ijp0cnVlfX0%3D&amp;disableSensitivityBanner=true&amp;storytellingChangeViewModeShortcutKeys=true&quot;"/>
+    <we:property name="datasetId" value="&quot;06486a2d-3ca7-435f-9107-43cff484d63a&quot;"/>
+    <we:property name="embedUrl" value="&quot;/reportEmbed?reportId=968cc6b9-2863-4028-bc1c-8026a357d191&amp;config=eyJjbHVzdGVyVXJsIjoiaHR0cHM6Ly9XQUJJLU5PUlRILUVVUk9QRS1PLVBSSU1BUlktcmVkaXJlY3QuYW5hbHlzaXMud2luZG93cy5uZXQiLCJlbWJlZEZlYXR1cmVzIjp7InVzYWdlTWV0cmljc1ZOZXh0Ijp0cnVlfX0%3D&amp;disableSensitivityBanner=true&amp;storytellingChangeViewModeShortcutKeys=true&quot;"/>
     <we:property name="initialStateBookmark" value="&quot;H4sIAAAAAAAAA6VVTW/bMAz9K4PPwUDqW7t1w05dP7AOvRTFQFF04dWJA9sp2hX975OSAr20COBdbImm3nukSPO5yd207enpnNbSfGm+DsP9msb7T9isms2r7eLi9Ozk5+nv85Oz78U8bOdu2EzNl+dmpvFO5utu2lFfEYrx5nbVUN9f0l3dtdRPsmq2Mk7Dhvrurxycy6d53MnLqpHHbT+MVCGvZpqlwj4U97Iv3PhZF0biuXuQK+H5YPUpxCix1UiaiW1g4OI2HRz2yt51qdB7+m/DZqZuU2iqTeU2M3uQ6DRA8czeVvvUbe76V8FvZ389bWtWunWJsGYj/Sm0FeflpYQTCGIrbetJ2ewwe8qwFCsiK06gnASnnEflSZZieeXZOGmTR405Wa8NL8XKwaQY0ObspWjCbJRZikU5g3MKAHQGLVYl8kux0KYUo7WWgFiBmJQW6zKpFAFoZyEBYLYZl2NBi4CM5NgHLJfgANXiGJ3RGnUgj04LWPJ2ca2ic61CFmvQimPSCMdrYpbHOQ2P71S+BAFvQtKWEIwS0HGpMqtzjMBK0IFmW8pNHa/8D5Wx8a1YLMnSpaEgJR/+Aw2wSmLx7GIWBohCy9FUssq1JtpQ7jMQh+SO18aHaMa19cdHDnwEAzE7u7ibXNYuBcuawUVvOSlcjBVLgM5HZRFVsMAmq8W14Zzl0k8tJCytKZI4h6UZ2wO+WZq1lHlWF8NunrbEckmbsr95brbjUIbY3Mnerwwt2mTJr+uxvn90s4wH6mvqd5V1P/2aPUlR06VejhyoM7HZy7qtj39IeRmtngcAAA==&quot;"/>
     <we:property name="isFiltersActionButtonVisible" value="true"/>
     <we:property name="isVisualContainerHeaderHidden" value="false"/>
-    <we:property name="pageDisplayName" value="&quot;Market Overiew&quot;"/>
-    <we:property name="pageName" value="&quot;53e1f1f2d663e523de3c&quot;"/>
-    <we:property name="reportEmbeddedTime" value="&quot;2026-05-06T14:19:09.724Z&quot;"/>
-    <we:property name="reportName" value="&quot;Depi_Grad 4.4&quot;"/>
+    <we:property name="pageDisplayName" value="&quot;Home&quot;"/>
+    <we:property name="pageName" value="&quot;7b899e9f31a3cac58c0c&quot;"/>
+    <we:property name="reportEmbeddedTime" value="&quot;2026-06-17T08:53:40.593Z&quot;"/>
+    <we:property name="reportName" value="&quot;Depi_Grad 4.5&quot;"/>
     <we:property name="reportState" value="&quot;CONNECTED&quot;"/>
-    <we:property name="reportUrl" value="&quot;/groups/me/reports/3457b0e3-007e-4692-a894-549b02af13e0/53e1f1f2d663e523de3c?bookmarkGuid=01a64edc-4a57-423b-a5d8-0f6aa1c36b53&amp;bookmarkUsage=1&amp;ctid=77255288-5298-4ea5-81aa-a13e604c30ac&amp;fromEntryPoint=export&amp;pbi_source=storytelling_addin&quot;"/>
+    <we:property name="reportUrl" value="&quot;/groups/me/reports/968cc6b9-2863-4028-bc1c-8026a357d191/7b899e9f31a3cac58c0c?bookmarkGuid=eb3c3190-d4e7-44bc-bc34-0b90fa08c88c&amp;bookmarkUsage=1&amp;ctid=77255288-5298-4ea5-81aa-a13e604c30ac&amp;fromEntryPoint=export&amp;pbi_source=storytelling_addin&quot;"/>
   </we:properties>
   <we:bindings/>
   <we:snapshot xmlns:r="http://schemas.openxmlformats.org/officeDocument/2006/relationships"/>

</xml_diff>